<commit_message>
Complete blue-corporate footer placeholders
</commit_message>
<xml_diff>
--- a/templates/blue-corporate.pptx
+++ b/templates/blue-corporate.pptx
@@ -2450,6 +2450,53 @@
       </p:sp>
       <p:sp>
         <p:nvSpPr>
+          <p:cNvPr id="6" name="Date Placeholder 5">
+            <a:extLst>
+              <a:ext uri="{FF2B5EF4-FFF2-40B4-BE49-F238E27FC236}">
+                <a16:creationId xmlns:a16="http://schemas.microsoft.com/office/drawing/2014/main" id="{DC92A910-0A08-40A7-B860-474129805EAB}"/>
+              </a:ext>
+            </a:extLst>
+          </p:cNvPr>
+          <p:cNvSpPr>
+            <a:spLocks noGrp="1"/>
+          </p:cNvSpPr>
+          <p:nvPr>
+            <p:ph type="dt" sz="quarter" idx="20"/>
+          </p:nvPr>
+        </p:nvSpPr>
+        <p:spPr>
+          <a:xfrm>
+            <a:off x="432000" y="6365893"/>
+            <a:ext cx="3200400" cy="226714"/>
+          </a:xfrm>
+          <a:prstGeom prst="rect">
+            <a:avLst/>
+          </a:prstGeom>
+        </p:spPr>
+        <p:txBody>
+          <a:bodyPr vert="horz" lIns="0" tIns="0" rIns="0" bIns="0" rtlCol="0" anchor="ctr"/>
+          <a:lstStyle>
+            <a:lvl1pPr algn="l">
+              <a:defRPr sz="1200">
+                <a:solidFill>
+                  <a:schemeClr val="tx1">
+                    <a:lumMod val="75000"/>
+                    <a:lumOff val="25000"/>
+                  </a:schemeClr>
+                </a:solidFill>
+              </a:defRPr>
+            </a:lvl1pPr>
+          </a:lstStyle>
+          <a:p>
+            <a:r>
+              <a:rPr lang="en-US" noProof="0" dirty="0"/>
+              <a:t>DATE</a:t>
+            </a:r>
+          </a:p>
+        </p:txBody>
+      </p:sp>
+      <p:sp>
+        <p:nvSpPr>
           <p:cNvPr id="5" name="Footer Placeholder 4">
             <a:extLst>
               <a:ext uri="{FF2B5EF4-FFF2-40B4-BE49-F238E27FC236}">
@@ -2466,7 +2513,7 @@
         </p:nvSpPr>
         <p:spPr>
           <a:xfrm>
-            <a:off x="432000" y="6365893"/>
+            <a:off x="4038600" y="6365893"/>
             <a:ext cx="4114800" cy="226714"/>
           </a:xfrm>
           <a:prstGeom prst="rect">

</xml_diff>

<commit_message>
Repair content-layout title and body hierarchy
</commit_message>
<xml_diff>
--- a/templates/blue-corporate.pptx
+++ b/templates/blue-corporate.pptx
@@ -1214,14 +1214,14 @@
         <p:spPr>
           <a:xfrm>
             <a:off x="841248" y="841248"/>
-            <a:ext cx="10479024" cy="557784"/>
+            <a:ext cx="10479024" cy="914400"/>
           </a:xfrm>
         </p:spPr>
         <p:txBody>
           <a:bodyPr anchor="t"/>
           <a:lstStyle>
             <a:lvl1pPr>
-              <a:defRPr sz="2000" cap="all" spc="300" baseline="0"/>
+              <a:defRPr sz="2800" cap="all" spc="300" baseline="0"/>
             </a:lvl1pPr>
           </a:lstStyle>
           <a:p>
@@ -1251,8 +1251,8 @@
         </p:nvSpPr>
         <p:spPr>
           <a:xfrm>
-            <a:off x="841248" y="1536827"/>
-            <a:ext cx="10479024" cy="4479925"/>
+            <a:off x="841248" y="1850000"/>
+            <a:ext cx="10479024" cy="4166752"/>
           </a:xfrm>
         </p:spPr>
         <p:txBody>
@@ -1267,19 +1267,19 @@
               <a:spcAft>
                 <a:spcPts val="0"/>
               </a:spcAft>
-              <a:defRPr sz="2800"/>
+              <a:defRPr sz="2000"/>
             </a:lvl1pPr>
             <a:lvl2pPr>
-              <a:defRPr sz="2800"/>
+              <a:defRPr sz="2000"/>
             </a:lvl2pPr>
             <a:lvl3pPr>
-              <a:defRPr sz="2400"/>
+              <a:defRPr sz="1600"/>
             </a:lvl3pPr>
             <a:lvl4pPr>
-              <a:defRPr sz="2400"/>
+              <a:defRPr sz="1600"/>
             </a:lvl4pPr>
             <a:lvl5pPr>
-              <a:defRPr sz="2000"/>
+              <a:defRPr sz="1400"/>
             </a:lvl5pPr>
           </a:lstStyle>
           <a:p>
@@ -2081,14 +2081,14 @@
         <p:spPr>
           <a:xfrm>
             <a:off x="841248" y="841248"/>
-            <a:ext cx="10479024" cy="557784"/>
+            <a:ext cx="10479024" cy="914400"/>
           </a:xfrm>
         </p:spPr>
         <p:txBody>
           <a:bodyPr anchor="t"/>
           <a:lstStyle>
             <a:lvl1pPr>
-              <a:defRPr sz="2000" cap="all" spc="300" baseline="0"/>
+              <a:defRPr sz="2800" cap="all" spc="300" baseline="0"/>
             </a:lvl1pPr>
           </a:lstStyle>
           <a:p>
@@ -2112,8 +2112,8 @@
         </p:nvSpPr>
         <p:spPr>
           <a:xfrm>
-            <a:off x="841248" y="1536827"/>
-            <a:ext cx="5057775" cy="4479925"/>
+            <a:off x="841248" y="1850000"/>
+            <a:ext cx="5057775" cy="4166752"/>
           </a:xfrm>
         </p:spPr>
         <p:txBody>
@@ -2173,8 +2173,8 @@
         </p:nvSpPr>
         <p:spPr>
           <a:xfrm>
-            <a:off x="6262497" y="1536827"/>
-            <a:ext cx="5057775" cy="4479925"/>
+            <a:off x="6262497" y="1850000"/>
+            <a:ext cx="5057775" cy="4166752"/>
           </a:xfrm>
         </p:spPr>
         <p:txBody>

</xml_diff>

<commit_message>
Repair reviewed blue heading, yellow closing and p-style column hierarchy
Adds guarded --blue-reusable-title, --yellow-closing-grouping and
--pstyle-column-hierarchy repairs and applies them: blue-corporate
Blank + Title heading 20->28pt with a two-line frame, modern-yellow
Closing title/subtitle widened to the content width, and the local
p-style Two Content root/child levels raised to 20/18pt. Only the two
affected layout previews and manifest entries are refreshed.

Skill-Sync-Exempt: template artwork repair, no agent-visible schema or response change

Co-Authored-By: Claude Opus 5.5 <noreply@anthropic.com>
</commit_message>
<xml_diff>
--- a/templates/blue-corporate.pptx
+++ b/templates/blue-corporate.pptx
@@ -2288,14 +2288,14 @@
         <p:spPr>
           <a:xfrm>
             <a:off x="841248" y="841248"/>
-            <a:ext cx="10479024" cy="557784"/>
+            <a:ext cx="10479024" cy="1016000"/>
           </a:xfrm>
         </p:spPr>
         <p:txBody>
           <a:bodyPr anchor="t"/>
           <a:lstStyle>
             <a:lvl1pPr>
-              <a:defRPr sz="2000" cap="all" spc="300" baseline="0"/>
+              <a:defRPr sz="2800" cap="all" spc="300" baseline="0"/>
             </a:lvl1pPr>
           </a:lstStyle>
           <a:p>

</xml_diff>

<commit_message>
Even out blue child and business column leading on dense continuations
blue-corporate One Content child levels (lvl3-5) inherited the master's
90% leading under 140% parents; give them the parent leading. The
business-template Two Content columns open from 110% to 120% together.
Native corner-circle and yellow-disc artwork is kept: reviewers found it
clear of text and the bead requires preserving artwork assets.

Skill-Sync-Exempt: template typography repair, no agent-visible schema or response change

Co-Authored-By: Claude Opus 5.5 <noreply@anthropic.com>
</commit_message>
<xml_diff>
--- a/templates/blue-corporate.pptx
+++ b/templates/blue-corporate.pptx
@@ -1276,12 +1276,21 @@
               <a:defRPr sz="2000"/>
             </a:lvl2pPr>
             <a:lvl3pPr>
+              <a:lnSpc>
+                <a:spcPct val="140000"/>
+              </a:lnSpc>
               <a:defRPr sz="1600"/>
             </a:lvl3pPr>
             <a:lvl4pPr>
+              <a:lnSpc>
+                <a:spcPct val="140000"/>
+              </a:lnSpc>
               <a:defRPr sz="1600"/>
             </a:lvl4pPr>
             <a:lvl5pPr>
+              <a:lnSpc>
+                <a:spcPct val="140000"/>
+              </a:lnSpc>
               <a:defRPr sz="1400"/>
             </a:lvl5pPr>
           </a:lstStyle>

</xml_diff>